<commit_message>
Limit this publication to reviewed Weeks 1-8 and standalone textbook
</commit_message>
<xml_diff>
--- a/week_09/week_09_nosql_models_json.pptx
+++ b/week_09/week_09_nosql_models_json.pptx
@@ -6046,337 +6046,337 @@
 </file>
 
 <file path=ppt/slides/slide11.xml><?xml version="1.0" encoding="utf-8"?>
-<ns0:sld xmlns:ns0="http://schemas.openxmlformats.org/presentationml/2006/main" xmlns:ns1="http://schemas.openxmlformats.org/drawingml/2006/main" xmlns:ns2="http://schemas.openxmlformats.org/officeDocument/2006/relationships" xmlns:ns3="http://schemas.microsoft.com/office/drawing/2014/main" xmlns:ns4="http://schemas.microsoft.com/office/powerpoint/2010/main">
-  <ns0:cSld>
-    <ns0:bg>
-      <ns0:bgPr>
-        <ns1:solidFill>
-          <ns1:srgbClr val="FCFCFA"/>
-        </ns1:solidFill>
-      </ns0:bgPr>
-    </ns0:bg>
-    <ns0:spTree>
-      <ns0:nvGrpSpPr>
-        <ns0:cNvPr id="1" name=""/>
-        <ns0:cNvGrpSpPr/>
-        <ns0:nvPr/>
-      </ns0:nvGrpSpPr>
-      <ns0:grpSpPr>
-        <ns1:xfrm/>
-      </ns0:grpSpPr>
-      <ns0:pic>
-        <ns0:nvPicPr>
-          <ns0:cNvPr id="14" name="" descr="Two nonzero vectors share an origin and have different lengths. Theta marks the angle between them, not the angle to an axis. Cosine equals their dot product divided by the product of their Euclidean lengths. Same-direction vectors have cosine one, perpendicular vectors zero, and opposite vectors negative one."/>
-          <ns0:cNvPicPr>
-            <ns1:picLocks noChangeAspect="1"/>
-          </ns0:cNvPicPr>
-          <ns0:nvPr/>
-        </ns0:nvPicPr>
-        <ns0:blipFill>
-          <ns1:blip ns2:embed="R933f1a713b4c4725"/>
-          <ns1:stretch/>
-        </ns0:blipFill>
-        <ns0:spPr>
-          <ns1:xfrm>
-            <ns1:off x="2235868" y="1647825"/>
-            <ns1:ext cx="7720263" cy="4191000"/>
-          </ns1:xfrm>
-          <ns1:prstGeom prst="rect">
-            <ns1:avLst/>
-          </ns1:prstGeom>
-        </ns0:spPr>
-      </ns0:pic>
-      <ns0:sp>
-        <ns0:nvSpPr>
-          <ns0:cNvPr id="9" name="eyebrow">
-            <ns1:extLst>
-              <ns1:ext uri="{FF2B5EF4-FFF2-40B4-BE49-F238E27FC236}">
-                <ns3:creationId id="{4539B5DB-FB59-4995-8E50-1C72E8013CF9}"/>
-              </ns1:ext>
-            </ns1:extLst>
-          </ns0:cNvPr>
-          <ns0:cNvSpPr>
-            <ns1:spLocks noGrp="1"/>
-          </ns0:cNvSpPr>
-          <ns0:nvPr/>
-        </ns0:nvSpPr>
-        <ns0:spPr>
-          <ns1:xfrm>
-            <ns1:off x="609600" y="295275"/>
-            <ns1:ext cx="5715000" cy="228600"/>
-          </ns1:xfrm>
-          <ns1:prstGeom prst="rect">
-            <ns1:avLst/>
-          </ns1:prstGeom>
-          <ns1:noFill/>
-          <ns1:ln w="0">
-            <ns1:noFill/>
-          </ns1:ln>
-        </ns0:spPr>
-        <ns0:txBody>
-          <ns1:bodyPr wrap="square" lIns="0" tIns="0" rIns="0" bIns="0" anchor="t">
-            <ns1:noAutofit/>
-          </ns1:bodyPr>
-          <ns1:lstStyle/>
-          <ns1:p>
-            <ns1:pPr>
-              <ns1:defRPr sz="1050" b="1">
-                <ns1:solidFill>
-                  <ns1:srgbClr val="214AE8"/>
-                </ns1:solidFill>
-                <ns1:latin typeface="Helvetica Neue"/>
-                <ns1:ea typeface="Helvetica Neue"/>
-                <ns1:cs typeface="Helvetica Neue"/>
-              </ns1:defRPr>
-            </ns1:pPr>
-            <ns1:r>
-              <ns1:rPr sz="1050" b="1">
-                <ns1:solidFill>
-                  <ns1:srgbClr val="214AE8"/>
-                </ns1:solidFill>
-                <ns1:latin typeface="Helvetica Neue"/>
-                <ns1:ea typeface="Helvetica Neue"/>
-                <ns1:cs typeface="Helvetica Neue"/>
-              </ns1:rPr>
-              <ns1:t>WEEK 09  /  CST4714</ns1:t>
-            </ns1:r>
-          </ns1:p>
-        </ns0:txBody>
-      </ns0:sp>
-      <ns0:sp>
-        <ns0:nvSpPr>
-          <ns0:cNvPr id="10" name="slide-title">
-            <ns1:extLst>
-              <ns1:ext uri="{FF2B5EF4-FFF2-40B4-BE49-F238E27FC236}">
-                <ns3:creationId id="{3B5F7C9C-B251-4A44-90D2-6C1B8402046B}"/>
-              </ns1:ext>
-            </ns1:extLst>
-          </ns0:cNvPr>
-          <ns0:cNvSpPr>
-            <ns1:spLocks noGrp="1"/>
-          </ns0:cNvSpPr>
-          <ns0:nvPr/>
-        </ns0:nvSpPr>
-        <ns0:spPr>
-          <ns1:xfrm>
-            <ns1:off x="609600" y="619125"/>
-            <ns1:ext cx="10972800" cy="628650"/>
-          </ns1:xfrm>
-          <ns1:prstGeom prst="rect">
-            <ns1:avLst/>
-          </ns1:prstGeom>
-          <ns1:noFill/>
-          <ns1:ln w="0">
-            <ns1:noFill/>
-          </ns1:ln>
-        </ns0:spPr>
-        <ns0:txBody>
-          <ns1:bodyPr wrap="square" lIns="0" tIns="0" rIns="0" bIns="0" anchor="t">
-            <ns1:noAutofit/>
-          </ns1:bodyPr>
-          <ns1:lstStyle/>
-          <ns1:p>
-            <ns1:pPr>
-              <ns1:defRPr sz="2775" b="1">
-                <ns1:solidFill>
-                  <ns1:srgbClr val="111827"/>
-                </ns1:solidFill>
-                <ns1:latin typeface="Helvetica Neue"/>
-                <ns1:ea typeface="Helvetica Neue"/>
-                <ns1:cs typeface="Helvetica Neue"/>
-              </ns1:defRPr>
-            </ns1:pPr>
-            <ns1:r>
-              <ns1:rPr sz="2775" b="1">
-                <ns1:solidFill>
-                  <ns1:srgbClr val="111827"/>
-                </ns1:solidFill>
-                <ns1:latin typeface="Helvetica Neue"/>
-                <ns1:ea typeface="Helvetica Neue"/>
-                <ns1:cs typeface="Helvetica Neue"/>
-              </ns1:rPr>
-              <ns1:t>Vector direction and length</ns1:t>
-            </ns1:r>
-          </ns1:p>
-        </ns0:txBody>
-      </ns0:sp>
-      <ns0:sp>
-        <ns0:nvSpPr>
-          <ns0:cNvPr id="11" name="">
-            <ns1:extLst>
-              <ns1:ext uri="{FF2B5EF4-FFF2-40B4-BE49-F238E27FC236}">
-                <ns3:creationId id="{6DE4B0B7-92EC-4554-87D6-7D9E91F93B99}"/>
-              </ns1:ext>
-            </ns1:extLst>
-          </ns0:cNvPr>
-          <ns0:cNvSpPr>
-            <ns1:spLocks noGrp="1"/>
-          </ns0:cNvSpPr>
-          <ns0:nvPr/>
-        </ns0:nvSpPr>
-        <ns0:spPr>
-          <ns1:xfrm>
-            <ns1:off x="609600" y="1295400"/>
-            <ns1:ext cx="10972800" cy="9525"/>
-          </ns1:xfrm>
-          <ns1:prstGeom prst="rect">
-            <ns1:avLst/>
-          </ns1:prstGeom>
-          <ns1:solidFill>
-            <ns1:srgbClr val="CBD5E1"/>
-          </ns1:solidFill>
-          <ns1:ln w="0">
-            <ns1:solidFill>
-              <ns1:srgbClr val="CBD5E1"/>
-            </ns1:solidFill>
-          </ns1:ln>
-        </ns0:spPr>
-      </ns0:sp>
-      <ns0:sp>
-        <ns0:nvSpPr>
-          <ns0:cNvPr id="12" name="slide-number">
-            <ns1:extLst>
-              <ns1:ext uri="{FF2B5EF4-FFF2-40B4-BE49-F238E27FC236}">
-                <ns3:creationId id="{04B303A4-F145-445D-96CA-E68DF1C661E0}"/>
-              </ns1:ext>
-            </ns1:extLst>
-          </ns0:cNvPr>
-          <ns0:cNvSpPr>
-            <ns1:spLocks noGrp="1"/>
-          </ns0:cNvSpPr>
-          <ns0:nvPr/>
-        </ns0:nvSpPr>
-        <ns0:spPr>
-          <ns1:xfrm>
-            <ns1:off x="11125200" y="6467475"/>
-            <ns1:ext cx="457200" cy="190500"/>
-          </ns1:xfrm>
-          <ns1:prstGeom prst="rect">
-            <ns1:avLst/>
-          </ns1:prstGeom>
-          <ns1:noFill/>
-          <ns1:ln w="0">
-            <ns1:noFill/>
-          </ns1:ln>
-        </ns0:spPr>
-        <ns0:txBody>
-          <ns1:bodyPr wrap="square" lIns="0" tIns="0" rIns="0" bIns="0" anchor="t">
-            <ns1:noAutofit/>
-          </ns1:bodyPr>
-          <ns1:lstStyle/>
-          <ns1:p>
-            <ns1:pPr>
-              <ns1:defRPr sz="900" b="0">
-                <ns1:solidFill>
-                  <ns1:srgbClr val="64748B"/>
-                </ns1:solidFill>
-                <ns1:latin typeface="Helvetica Neue"/>
-                <ns1:ea typeface="Helvetica Neue"/>
-                <ns1:cs typeface="Helvetica Neue"/>
-              </ns1:defRPr>
-            </ns1:pPr>
-            <ns1:r>
-              <ns1:rPr sz="900" b="0">
-                <ns1:solidFill>
-                  <ns1:srgbClr val="64748B"/>
-                </ns1:solidFill>
-                <ns1:latin typeface="Helvetica Neue"/>
-                <ns1:ea typeface="Helvetica Neue"/>
-                <ns1:cs typeface="Helvetica Neue"/>
-              </ns1:rPr>
-              <ns1:t>11</ns1:t>
-            </ns1:r>
-          </ns1:p>
-        </ns0:txBody>
-      </ns0:sp>
-      <ns0:sp>
-        <ns0:nvSpPr>
-          <ns0:cNvPr id="13" name="geometry-caption">
-            <ns1:extLst>
-              <ns1:ext uri="{FF2B5EF4-FFF2-40B4-BE49-F238E27FC236}">
-                <ns3:creationId id="{706D8FB7-EABB-4CF1-8DEB-C7B0A4EEC2FF}"/>
-              </ns1:ext>
-            </ns1:extLst>
-          </ns0:cNvPr>
-          <ns0:cNvSpPr>
-            <ns1:spLocks noGrp="1"/>
-          </ns0:cNvSpPr>
-          <ns0:nvPr/>
-        </ns0:nvSpPr>
-        <ns0:spPr>
-          <ns1:xfrm>
-            <ns1:off x="723900" y="5895975"/>
-            <ns1:ext cx="10668000" cy="628650"/>
-          </ns1:xfrm>
-          <ns1:prstGeom prst="rect">
-            <ns1:avLst/>
-          </ns1:prstGeom>
-          <ns1:noFill/>
-          <ns1:ln w="0">
-            <ns1:noFill/>
-          </ns1:ln>
-        </ns0:spPr>
-        <ns0:txBody>
-          <ns1:bodyPr wrap="square" lIns="0" tIns="0" rIns="0" bIns="0" anchor="t">
-            <ns1:noAutofit/>
-          </ns1:bodyPr>
-          <ns1:lstStyle/>
-          <ns1:p>
-            <ns1:pPr>
-              <ns1:defRPr sz="2025" b="0">
-                <ns1:solidFill>
-                  <ns1:srgbClr val="111827"/>
-                </ns1:solidFill>
-                <ns1:latin typeface="Helvetica Neue"/>
-                <ns1:ea typeface="Helvetica Neue"/>
-                <ns1:cs typeface="Helvetica Neue"/>
-              </ns1:defRPr>
-            </ns1:pPr>
-            <ns1:r>
-              <ns1:rPr sz="2025" b="0">
-                <ns1:solidFill>
-                  <ns1:srgbClr val="111827"/>
-                </ns1:solidFill>
-                <ns1:latin typeface="Helvetica Neue"/>
-                <ns1:ea typeface="Helvetica Neue"/>
-                <ns1:cs typeface="Helvetica Neue"/>
-              </ns1:rPr>
-              <ns1:t>Theta is the angle between u and v. Scaling a vector by a positive factor</ns1:t>
-            </ns1:r>
-          </ns1:p>
-          <ns1:p>
-            <ns1:pPr>
-              <ns1:defRPr sz="2025" b="0">
-                <ns1:solidFill>
-                  <ns1:srgbClr val="111827"/>
-                </ns1:solidFill>
-                <ns1:latin typeface="Helvetica Neue"/>
-                <ns1:ea typeface="Helvetica Neue"/>
-                <ns1:cs typeface="Helvetica Neue"/>
-              </ns1:defRPr>
-            </ns1:pPr>
-            <ns1:r>
-              <ns1:rPr sz="2025" b="0">
-                <ns1:solidFill>
-                  <ns1:srgbClr val="111827"/>
-                </ns1:solidFill>
-                <ns1:latin typeface="Helvetica Neue"/>
-                <ns1:ea typeface="Helvetica Neue"/>
-                <ns1:cs typeface="Helvetica Neue"/>
-              </ns1:rPr>
-              <ns1:t>changes its length but preserves its direction.</ns1:t>
-            </ns1:r>
-          </ns1:p>
-        </ns0:txBody>
-      </ns0:sp>
-    </ns0:spTree>
-    <ns0:extLst>
-      <ns0:ext uri="{BB962C8B-B14F-4D97-AF65-F5344CB8AC3E}">
-        <ns4:creationId val="1145525781"/>
-      </ns0:ext>
-    </ns0:extLst>
-  </ns0:cSld>
-</ns0:sld>
+<p:sld xmlns:p="http://schemas.openxmlformats.org/presentationml/2006/main">
+  <p:cSld>
+    <p:bg>
+      <p:bgPr>
+        <a:solidFill xmlns:a="http://schemas.openxmlformats.org/drawingml/2006/main">
+          <a:srgbClr val="FCFCFA"/>
+        </a:solidFill>
+      </p:bgPr>
+    </p:bg>
+    <p:spTree>
+      <p:nvGrpSpPr>
+        <p:cNvPr id="1" name=""/>
+        <p:cNvGrpSpPr/>
+        <p:nvPr/>
+      </p:nvGrpSpPr>
+      <p:grpSpPr>
+        <a:xfrm xmlns:a="http://schemas.openxmlformats.org/drawingml/2006/main"/>
+      </p:grpSpPr>
+      <p:pic>
+        <p:nvPicPr>
+          <p:cNvPr id="14" name=""/>
+          <p:cNvPicPr>
+            <a:picLocks xmlns:a="http://schemas.openxmlformats.org/drawingml/2006/main" noChangeAspect="1"/>
+          </p:cNvPicPr>
+          <p:nvPr/>
+        </p:nvPicPr>
+        <p:blipFill>
+          <a:blip xmlns:r="http://schemas.openxmlformats.org/officeDocument/2006/relationships" xmlns:a="http://schemas.openxmlformats.org/drawingml/2006/main" r:embed="R933f1a713b4c4725"/>
+          <a:stretch xmlns:a="http://schemas.openxmlformats.org/drawingml/2006/main"/>
+        </p:blipFill>
+        <p:spPr>
+          <a:xfrm xmlns:a="http://schemas.openxmlformats.org/drawingml/2006/main">
+            <a:off x="2235868" y="1647825"/>
+            <a:ext cx="7720263" cy="4191000"/>
+          </a:xfrm>
+          <a:prstGeom xmlns:a="http://schemas.openxmlformats.org/drawingml/2006/main" prst="rect">
+            <a:avLst/>
+          </a:prstGeom>
+        </p:spPr>
+      </p:pic>
+      <p:sp>
+        <p:nvSpPr>
+          <p:cNvPr id="9" name="eyebrow">
+            <a:extLst xmlns:a="http://schemas.openxmlformats.org/drawingml/2006/main">
+              <a:ext uri="{FF2B5EF4-FFF2-40B4-BE49-F238E27FC236}">
+                <a16:creationId xmlns:a16="http://schemas.microsoft.com/office/drawing/2014/main" id="{4539B5DB-FB59-4995-8E50-1C72E8013CF9}"/>
+              </a:ext>
+            </a:extLst>
+          </p:cNvPr>
+          <p:cNvSpPr>
+            <a:spLocks xmlns:a="http://schemas.openxmlformats.org/drawingml/2006/main" noGrp="1"/>
+          </p:cNvSpPr>
+          <p:nvPr/>
+        </p:nvSpPr>
+        <p:spPr>
+          <a:xfrm xmlns:a="http://schemas.openxmlformats.org/drawingml/2006/main">
+            <a:off x="609600" y="295275"/>
+            <a:ext cx="5715000" cy="228600"/>
+          </a:xfrm>
+          <a:prstGeom xmlns:a="http://schemas.openxmlformats.org/drawingml/2006/main" prst="rect">
+            <a:avLst/>
+          </a:prstGeom>
+          <a:noFill xmlns:a="http://schemas.openxmlformats.org/drawingml/2006/main"/>
+          <a:ln xmlns:a="http://schemas.openxmlformats.org/drawingml/2006/main" w="0">
+            <a:noFill/>
+          </a:ln>
+        </p:spPr>
+        <p:txBody>
+          <a:bodyPr xmlns:a="http://schemas.openxmlformats.org/drawingml/2006/main" wrap="square" lIns="0" tIns="0" rIns="0" bIns="0" anchor="t">
+            <a:noAutofit/>
+          </a:bodyPr>
+          <a:lstStyle xmlns:a="http://schemas.openxmlformats.org/drawingml/2006/main"/>
+          <a:p xmlns:a="http://schemas.openxmlformats.org/drawingml/2006/main">
+            <a:pPr>
+              <a:defRPr sz="1050" b="1">
+                <a:solidFill>
+                  <a:srgbClr val="214AE8"/>
+                </a:solidFill>
+                <a:latin typeface="Helvetica Neue"/>
+                <a:ea typeface="Helvetica Neue"/>
+                <a:cs typeface="Helvetica Neue"/>
+              </a:defRPr>
+            </a:pPr>
+            <a:r>
+              <a:rPr sz="1050" b="1">
+                <a:solidFill>
+                  <a:srgbClr val="214AE8"/>
+                </a:solidFill>
+                <a:latin typeface="Helvetica Neue"/>
+                <a:ea typeface="Helvetica Neue"/>
+                <a:cs typeface="Helvetica Neue"/>
+              </a:rPr>
+              <a:t>WEEK 09  /  CST4714</a:t>
+            </a:r>
+          </a:p>
+        </p:txBody>
+      </p:sp>
+      <p:sp>
+        <p:nvSpPr>
+          <p:cNvPr id="10" name="slide-title">
+            <a:extLst xmlns:a="http://schemas.openxmlformats.org/drawingml/2006/main">
+              <a:ext uri="{FF2B5EF4-FFF2-40B4-BE49-F238E27FC236}">
+                <a16:creationId xmlns:a16="http://schemas.microsoft.com/office/drawing/2014/main" id="{3B5F7C9C-B251-4A44-90D2-6C1B8402046B}"/>
+              </a:ext>
+            </a:extLst>
+          </p:cNvPr>
+          <p:cNvSpPr>
+            <a:spLocks xmlns:a="http://schemas.openxmlformats.org/drawingml/2006/main" noGrp="1"/>
+          </p:cNvSpPr>
+          <p:nvPr/>
+        </p:nvSpPr>
+        <p:spPr>
+          <a:xfrm xmlns:a="http://schemas.openxmlformats.org/drawingml/2006/main">
+            <a:off x="609600" y="619125"/>
+            <a:ext cx="10972800" cy="628650"/>
+          </a:xfrm>
+          <a:prstGeom xmlns:a="http://schemas.openxmlformats.org/drawingml/2006/main" prst="rect">
+            <a:avLst/>
+          </a:prstGeom>
+          <a:noFill xmlns:a="http://schemas.openxmlformats.org/drawingml/2006/main"/>
+          <a:ln xmlns:a="http://schemas.openxmlformats.org/drawingml/2006/main" w="0">
+            <a:noFill/>
+          </a:ln>
+        </p:spPr>
+        <p:txBody>
+          <a:bodyPr xmlns:a="http://schemas.openxmlformats.org/drawingml/2006/main" wrap="square" lIns="0" tIns="0" rIns="0" bIns="0" anchor="t">
+            <a:noAutofit/>
+          </a:bodyPr>
+          <a:lstStyle xmlns:a="http://schemas.openxmlformats.org/drawingml/2006/main"/>
+          <a:p xmlns:a="http://schemas.openxmlformats.org/drawingml/2006/main">
+            <a:pPr>
+              <a:defRPr sz="2775" b="1">
+                <a:solidFill>
+                  <a:srgbClr val="111827"/>
+                </a:solidFill>
+                <a:latin typeface="Helvetica Neue"/>
+                <a:ea typeface="Helvetica Neue"/>
+                <a:cs typeface="Helvetica Neue"/>
+              </a:defRPr>
+            </a:pPr>
+            <a:r>
+              <a:rPr sz="2775" b="1">
+                <a:solidFill>
+                  <a:srgbClr val="111827"/>
+                </a:solidFill>
+                <a:latin typeface="Helvetica Neue"/>
+                <a:ea typeface="Helvetica Neue"/>
+                <a:cs typeface="Helvetica Neue"/>
+              </a:rPr>
+              <a:t>Vector direction and length</a:t>
+            </a:r>
+          </a:p>
+        </p:txBody>
+      </p:sp>
+      <p:sp>
+        <p:nvSpPr>
+          <p:cNvPr id="11" name="">
+            <a:extLst xmlns:a="http://schemas.openxmlformats.org/drawingml/2006/main">
+              <a:ext uri="{FF2B5EF4-FFF2-40B4-BE49-F238E27FC236}">
+                <a16:creationId xmlns:a16="http://schemas.microsoft.com/office/drawing/2014/main" id="{6DE4B0B7-92EC-4554-87D6-7D9E91F93B99}"/>
+              </a:ext>
+            </a:extLst>
+          </p:cNvPr>
+          <p:cNvSpPr>
+            <a:spLocks xmlns:a="http://schemas.openxmlformats.org/drawingml/2006/main" noGrp="1"/>
+          </p:cNvSpPr>
+          <p:nvPr/>
+        </p:nvSpPr>
+        <p:spPr>
+          <a:xfrm xmlns:a="http://schemas.openxmlformats.org/drawingml/2006/main">
+            <a:off x="609600" y="1295400"/>
+            <a:ext cx="10972800" cy="9525"/>
+          </a:xfrm>
+          <a:prstGeom xmlns:a="http://schemas.openxmlformats.org/drawingml/2006/main" prst="rect">
+            <a:avLst/>
+          </a:prstGeom>
+          <a:solidFill xmlns:a="http://schemas.openxmlformats.org/drawingml/2006/main">
+            <a:srgbClr val="CBD5E1"/>
+          </a:solidFill>
+          <a:ln xmlns:a="http://schemas.openxmlformats.org/drawingml/2006/main" w="0">
+            <a:solidFill>
+              <a:srgbClr val="CBD5E1"/>
+            </a:solidFill>
+          </a:ln>
+        </p:spPr>
+      </p:sp>
+      <p:sp>
+        <p:nvSpPr>
+          <p:cNvPr id="12" name="slide-number">
+            <a:extLst xmlns:a="http://schemas.openxmlformats.org/drawingml/2006/main">
+              <a:ext uri="{FF2B5EF4-FFF2-40B4-BE49-F238E27FC236}">
+                <a16:creationId xmlns:a16="http://schemas.microsoft.com/office/drawing/2014/main" id="{04B303A4-F145-445D-96CA-E68DF1C661E0}"/>
+              </a:ext>
+            </a:extLst>
+          </p:cNvPr>
+          <p:cNvSpPr>
+            <a:spLocks xmlns:a="http://schemas.openxmlformats.org/drawingml/2006/main" noGrp="1"/>
+          </p:cNvSpPr>
+          <p:nvPr/>
+        </p:nvSpPr>
+        <p:spPr>
+          <a:xfrm xmlns:a="http://schemas.openxmlformats.org/drawingml/2006/main">
+            <a:off x="11125200" y="6467475"/>
+            <a:ext cx="457200" cy="190500"/>
+          </a:xfrm>
+          <a:prstGeom xmlns:a="http://schemas.openxmlformats.org/drawingml/2006/main" prst="rect">
+            <a:avLst/>
+          </a:prstGeom>
+          <a:noFill xmlns:a="http://schemas.openxmlformats.org/drawingml/2006/main"/>
+          <a:ln xmlns:a="http://schemas.openxmlformats.org/drawingml/2006/main" w="0">
+            <a:noFill/>
+          </a:ln>
+        </p:spPr>
+        <p:txBody>
+          <a:bodyPr xmlns:a="http://schemas.openxmlformats.org/drawingml/2006/main" wrap="square" lIns="0" tIns="0" rIns="0" bIns="0" anchor="t">
+            <a:noAutofit/>
+          </a:bodyPr>
+          <a:lstStyle xmlns:a="http://schemas.openxmlformats.org/drawingml/2006/main"/>
+          <a:p xmlns:a="http://schemas.openxmlformats.org/drawingml/2006/main">
+            <a:pPr>
+              <a:defRPr sz="900" b="0">
+                <a:solidFill>
+                  <a:srgbClr val="64748B"/>
+                </a:solidFill>
+                <a:latin typeface="Helvetica Neue"/>
+                <a:ea typeface="Helvetica Neue"/>
+                <a:cs typeface="Helvetica Neue"/>
+              </a:defRPr>
+            </a:pPr>
+            <a:r>
+              <a:rPr sz="900" b="0">
+                <a:solidFill>
+                  <a:srgbClr val="64748B"/>
+                </a:solidFill>
+                <a:latin typeface="Helvetica Neue"/>
+                <a:ea typeface="Helvetica Neue"/>
+                <a:cs typeface="Helvetica Neue"/>
+              </a:rPr>
+              <a:t>11</a:t>
+            </a:r>
+          </a:p>
+        </p:txBody>
+      </p:sp>
+      <p:sp>
+        <p:nvSpPr>
+          <p:cNvPr id="13" name="geometry-caption">
+            <a:extLst xmlns:a="http://schemas.openxmlformats.org/drawingml/2006/main">
+              <a:ext uri="{FF2B5EF4-FFF2-40B4-BE49-F238E27FC236}">
+                <a16:creationId xmlns:a16="http://schemas.microsoft.com/office/drawing/2014/main" id="{706D8FB7-EABB-4CF1-8DEB-C7B0A4EEC2FF}"/>
+              </a:ext>
+            </a:extLst>
+          </p:cNvPr>
+          <p:cNvSpPr>
+            <a:spLocks xmlns:a="http://schemas.openxmlformats.org/drawingml/2006/main" noGrp="1"/>
+          </p:cNvSpPr>
+          <p:nvPr/>
+        </p:nvSpPr>
+        <p:spPr>
+          <a:xfrm xmlns:a="http://schemas.openxmlformats.org/drawingml/2006/main">
+            <a:off x="723900" y="5895975"/>
+            <a:ext cx="10668000" cy="628650"/>
+          </a:xfrm>
+          <a:prstGeom xmlns:a="http://schemas.openxmlformats.org/drawingml/2006/main" prst="rect">
+            <a:avLst/>
+          </a:prstGeom>
+          <a:noFill xmlns:a="http://schemas.openxmlformats.org/drawingml/2006/main"/>
+          <a:ln xmlns:a="http://schemas.openxmlformats.org/drawingml/2006/main" w="0">
+            <a:noFill/>
+          </a:ln>
+        </p:spPr>
+        <p:txBody>
+          <a:bodyPr xmlns:a="http://schemas.openxmlformats.org/drawingml/2006/main" wrap="square" lIns="0" tIns="0" rIns="0" bIns="0" anchor="t">
+            <a:noAutofit/>
+          </a:bodyPr>
+          <a:lstStyle xmlns:a="http://schemas.openxmlformats.org/drawingml/2006/main"/>
+          <a:p xmlns:a="http://schemas.openxmlformats.org/drawingml/2006/main">
+            <a:pPr>
+              <a:defRPr sz="2025" b="0">
+                <a:solidFill>
+                  <a:srgbClr val="111827"/>
+                </a:solidFill>
+                <a:latin typeface="Helvetica Neue"/>
+                <a:ea typeface="Helvetica Neue"/>
+                <a:cs typeface="Helvetica Neue"/>
+              </a:defRPr>
+            </a:pPr>
+            <a:r>
+              <a:rPr sz="2025" b="0">
+                <a:solidFill>
+                  <a:srgbClr val="111827"/>
+                </a:solidFill>
+                <a:latin typeface="Helvetica Neue"/>
+                <a:ea typeface="Helvetica Neue"/>
+                <a:cs typeface="Helvetica Neue"/>
+              </a:rPr>
+              <a:t>Theta is the angle between u and v. Scaling a vector by a positive factor</a:t>
+            </a:r>
+          </a:p>
+          <a:p xmlns:a="http://schemas.openxmlformats.org/drawingml/2006/main">
+            <a:pPr>
+              <a:defRPr sz="2025" b="0">
+                <a:solidFill>
+                  <a:srgbClr val="111827"/>
+                </a:solidFill>
+                <a:latin typeface="Helvetica Neue"/>
+                <a:ea typeface="Helvetica Neue"/>
+                <a:cs typeface="Helvetica Neue"/>
+              </a:defRPr>
+            </a:pPr>
+            <a:r>
+              <a:rPr sz="2025" b="0">
+                <a:solidFill>
+                  <a:srgbClr val="111827"/>
+                </a:solidFill>
+                <a:latin typeface="Helvetica Neue"/>
+                <a:ea typeface="Helvetica Neue"/>
+                <a:cs typeface="Helvetica Neue"/>
+              </a:rPr>
+              <a:t>changes its length but preserves its direction.</a:t>
+            </a:r>
+          </a:p>
+        </p:txBody>
+      </p:sp>
+    </p:spTree>
+    <p:extLst>
+      <p:ext uri="{BB962C8B-B14F-4D97-AF65-F5344CB8AC3E}">
+        <p14:creationId xmlns:p14="http://schemas.microsoft.com/office/powerpoint/2010/main" val="1145525781"/>
+      </p:ext>
+    </p:extLst>
+  </p:cSld>
+</p:sld>
 </file>
 
 <file path=ppt/slides/slide12.xml><?xml version="1.0" encoding="utf-8"?>
@@ -19978,456 +19978,456 @@
 </file>
 
 <file path=ppt/slides/slide4.xml><?xml version="1.0" encoding="utf-8"?>
-<ns0:sld xmlns:ns0="http://schemas.openxmlformats.org/presentationml/2006/main" xmlns:ns1="http://schemas.openxmlformats.org/drawingml/2006/main" xmlns:ns2="http://schemas.openxmlformats.org/officeDocument/2006/relationships" xmlns:ns3="http://schemas.microsoft.com/office/drawing/2014/main" xmlns:ns4="http://schemas.microsoft.com/office/powerpoint/2010/main">
-  <ns0:cSld>
-    <ns0:bg>
-      <ns0:bgPr>
-        <ns1:solidFill>
-          <ns1:srgbClr val="FCFCFA"/>
-        </ns1:solidFill>
-      </ns0:bgPr>
-    </ns0:bg>
-    <ns0:spTree>
-      <ns0:nvGrpSpPr>
-        <ns0:cNvPr id="1" name=""/>
-        <ns0:cNvGrpSpPr/>
-        <ns0:nvPr/>
-      </ns0:nvGrpSpPr>
-      <ns0:grpSpPr>
-        <ns1:xfrm/>
-      </ns0:grpSpPr>
-      <ns0:pic>
-        <ns0:nvPicPr>
-          <ns0:cNvPr id="16" name="" descr="The workload question branches to five model families: key-value for exact-key lookup, wide-column for sparse rows by access key, document for a bounded nested aggregate, graph for relationship paths, and vector search for semantic neighbors. These are access-pattern comparisons, not mutually exclusive product categories."/>
-          <ns0:cNvPicPr>
-            <ns1:picLocks noChangeAspect="1"/>
-          </ns0:cNvPicPr>
-          <ns0:nvPr/>
-        </ns0:nvPicPr>
-        <ns0:blipFill>
-          <ns1:blip ns2:embed="R944d24afa02f4e5a"/>
-          <ns1:stretch/>
-        </ns0:blipFill>
-        <ns0:spPr>
-          <ns1:xfrm>
-            <ns1:off x="666750" y="1676400"/>
-            <ns1:ext cx="5657850" cy="4114800"/>
-          </ns1:xfrm>
-          <ns1:prstGeom prst="rect">
-            <ns1:avLst/>
-          </ns1:prstGeom>
-        </ns0:spPr>
-      </ns0:pic>
-      <ns0:sp>
-        <ns0:nvSpPr>
-          <ns0:cNvPr id="9" name="eyebrow">
-            <ns1:extLst>
-              <ns1:ext uri="{FF2B5EF4-FFF2-40B4-BE49-F238E27FC236}">
-                <ns3:creationId id="{468F18FB-D37E-4965-B1FB-8887D3F72C10}"/>
-              </ns1:ext>
-            </ns1:extLst>
-          </ns0:cNvPr>
-          <ns0:cNvSpPr>
-            <ns1:spLocks noGrp="1"/>
-          </ns0:cNvSpPr>
-          <ns0:nvPr/>
-        </ns0:nvSpPr>
-        <ns0:spPr>
-          <ns1:xfrm>
-            <ns1:off x="609600" y="295275"/>
-            <ns1:ext cx="5715000" cy="228600"/>
-          </ns1:xfrm>
-          <ns1:prstGeom prst="rect">
-            <ns1:avLst/>
-          </ns1:prstGeom>
-          <ns1:noFill/>
-          <ns1:ln w="0">
-            <ns1:noFill/>
-          </ns1:ln>
-        </ns0:spPr>
-        <ns0:txBody>
-          <ns1:bodyPr wrap="square" lIns="0" tIns="0" rIns="0" bIns="0" anchor="t">
-            <ns1:noAutofit/>
-          </ns1:bodyPr>
-          <ns1:lstStyle/>
-          <ns1:p>
-            <ns1:pPr>
-              <ns1:defRPr sz="1050" b="1">
-                <ns1:solidFill>
-                  <ns1:srgbClr val="214AE8"/>
-                </ns1:solidFill>
-                <ns1:latin typeface="Helvetica Neue"/>
-                <ns1:ea typeface="Helvetica Neue"/>
-                <ns1:cs typeface="Helvetica Neue"/>
-              </ns1:defRPr>
-            </ns1:pPr>
-            <ns1:r>
-              <ns1:rPr sz="1050" b="1">
-                <ns1:solidFill>
-                  <ns1:srgbClr val="214AE8"/>
-                </ns1:solidFill>
-                <ns1:latin typeface="Helvetica Neue"/>
-                <ns1:ea typeface="Helvetica Neue"/>
-                <ns1:cs typeface="Helvetica Neue"/>
-              </ns1:rPr>
-              <ns1:t>WEEK 09  /  CST4714</ns1:t>
-            </ns1:r>
-          </ns1:p>
-        </ns0:txBody>
-      </ns0:sp>
-      <ns0:sp>
-        <ns0:nvSpPr>
-          <ns0:cNvPr id="10" name="slide-title">
-            <ns1:extLst>
-              <ns1:ext uri="{FF2B5EF4-FFF2-40B4-BE49-F238E27FC236}">
-                <ns3:creationId id="{558CB877-064B-4830-BC43-3DAAEC31D314}"/>
-              </ns1:ext>
-            </ns1:extLst>
-          </ns0:cNvPr>
-          <ns0:cNvSpPr>
-            <ns1:spLocks noGrp="1"/>
-          </ns0:cNvSpPr>
-          <ns0:nvPr/>
-        </ns0:nvSpPr>
-        <ns0:spPr>
-          <ns1:xfrm>
-            <ns1:off x="609600" y="619125"/>
-            <ns1:ext cx="10972800" cy="628650"/>
-          </ns1:xfrm>
-          <ns1:prstGeom prst="rect">
-            <ns1:avLst/>
-          </ns1:prstGeom>
-          <ns1:noFill/>
-          <ns1:ln w="0">
-            <ns1:noFill/>
-          </ns1:ln>
-        </ns0:spPr>
-        <ns0:txBody>
-          <ns1:bodyPr wrap="square" lIns="0" tIns="0" rIns="0" bIns="0" anchor="t">
-            <ns1:noAutofit/>
-          </ns1:bodyPr>
-          <ns1:lstStyle/>
-          <ns1:p>
-            <ns1:pPr>
-              <ns1:defRPr sz="2775" b="1">
-                <ns1:solidFill>
-                  <ns1:srgbClr val="111827"/>
-                </ns1:solidFill>
-                <ns1:latin typeface="Helvetica Neue"/>
-                <ns1:ea typeface="Helvetica Neue"/>
-                <ns1:cs typeface="Helvetica Neue"/>
-              </ns1:defRPr>
-            </ns1:pPr>
-            <ns1:r>
-              <ns1:rPr sz="2775" b="1">
-                <ns1:solidFill>
-                  <ns1:srgbClr val="111827"/>
-                </ns1:solidFill>
-                <ns1:latin typeface="Helvetica Neue"/>
-                <ns1:ea typeface="Helvetica Neue"/>
-                <ns1:cs typeface="Helvetica Neue"/>
-              </ns1:rPr>
-              <ns1:t>Model families and access patterns</ns1:t>
-            </ns1:r>
-          </ns1:p>
-        </ns0:txBody>
-      </ns0:sp>
-      <ns0:sp>
-        <ns0:nvSpPr>
-          <ns0:cNvPr id="11" name="">
-            <ns1:extLst>
-              <ns1:ext uri="{FF2B5EF4-FFF2-40B4-BE49-F238E27FC236}">
-                <ns3:creationId id="{AF601EED-1672-4E16-B0E8-C6D6AACA4113}"/>
-              </ns1:ext>
-            </ns1:extLst>
-          </ns0:cNvPr>
-          <ns0:cNvSpPr>
-            <ns1:spLocks noGrp="1"/>
-          </ns0:cNvSpPr>
-          <ns0:nvPr/>
-        </ns0:nvSpPr>
-        <ns0:spPr>
-          <ns1:xfrm>
-            <ns1:off x="609600" y="1295400"/>
-            <ns1:ext cx="10972800" cy="9525"/>
-          </ns1:xfrm>
-          <ns1:prstGeom prst="rect">
-            <ns1:avLst/>
-          </ns1:prstGeom>
-          <ns1:solidFill>
-            <ns1:srgbClr val="CBD5E1"/>
-          </ns1:solidFill>
-          <ns1:ln w="0">
-            <ns1:solidFill>
-              <ns1:srgbClr val="CBD5E1"/>
-            </ns1:solidFill>
-          </ns1:ln>
-        </ns0:spPr>
-      </ns0:sp>
-      <ns0:sp>
-        <ns0:nvSpPr>
-          <ns0:cNvPr id="12" name="slide-number">
-            <ns1:extLst>
-              <ns1:ext uri="{FF2B5EF4-FFF2-40B4-BE49-F238E27FC236}">
-                <ns3:creationId id="{939911BD-2E67-4A5D-A723-C95C82DB1C34}"/>
-              </ns1:ext>
-            </ns1:extLst>
-          </ns0:cNvPr>
-          <ns0:cNvSpPr>
-            <ns1:spLocks noGrp="1"/>
-          </ns0:cNvSpPr>
-          <ns0:nvPr/>
-        </ns0:nvSpPr>
-        <ns0:spPr>
-          <ns1:xfrm>
-            <ns1:off x="11125200" y="6467475"/>
-            <ns1:ext cx="457200" cy="190500"/>
-          </ns1:xfrm>
-          <ns1:prstGeom prst="rect">
-            <ns1:avLst/>
-          </ns1:prstGeom>
-          <ns1:noFill/>
-          <ns1:ln w="0">
-            <ns1:noFill/>
-          </ns1:ln>
-        </ns0:spPr>
-        <ns0:txBody>
-          <ns1:bodyPr wrap="square" lIns="0" tIns="0" rIns="0" bIns="0" anchor="t">
-            <ns1:noAutofit/>
-          </ns1:bodyPr>
-          <ns1:lstStyle/>
-          <ns1:p>
-            <ns1:pPr>
-              <ns1:defRPr sz="900" b="0">
-                <ns1:solidFill>
-                  <ns1:srgbClr val="64748B"/>
-                </ns1:solidFill>
-                <ns1:latin typeface="Helvetica Neue"/>
-                <ns1:ea typeface="Helvetica Neue"/>
-                <ns1:cs typeface="Helvetica Neue"/>
-              </ns1:defRPr>
-            </ns1:pPr>
-            <ns1:r>
-              <ns1:rPr sz="900" b="0">
-                <ns1:solidFill>
-                  <ns1:srgbClr val="64748B"/>
-                </ns1:solidFill>
-                <ns1:latin typeface="Helvetica Neue"/>
-                <ns1:ea typeface="Helvetica Neue"/>
-                <ns1:cs typeface="Helvetica Neue"/>
-              </ns1:rPr>
-              <ns1:t>04</ns1:t>
-            </ns1:r>
-          </ns1:p>
-        </ns0:txBody>
-      </ns0:sp>
-      <ns0:sp>
-        <ns0:nvSpPr>
-          <ns0:cNvPr id="13" name="access-definition">
-            <ns1:extLst>
-              <ns1:ext uri="{FF2B5EF4-FFF2-40B4-BE49-F238E27FC236}">
-                <ns3:creationId id="{9AC8372B-6E76-427A-9731-2D8B3AFC2E15}"/>
-              </ns1:ext>
-            </ns1:extLst>
-          </ns0:cNvPr>
-          <ns0:cNvSpPr>
-            <ns1:spLocks noGrp="1"/>
-          </ns0:cNvSpPr>
-          <ns0:nvPr/>
-        </ns0:nvSpPr>
-        <ns0:spPr>
-          <ns1:xfrm>
-            <ns1:off x="6848475" y="1943100"/>
-            <ns1:ext cx="4667250" cy="1352550"/>
-          </ns1:xfrm>
-          <ns1:prstGeom prst="rect">
-            <ns1:avLst/>
-          </ns1:prstGeom>
-          <ns1:noFill/>
-          <ns1:ln w="0">
-            <ns1:noFill/>
-          </ns1:ln>
-        </ns0:spPr>
-        <ns0:txBody>
-          <ns1:bodyPr wrap="square" lIns="0" tIns="0" rIns="0" bIns="0" anchor="t">
-            <ns1:noAutofit/>
-          </ns1:bodyPr>
-          <ns1:lstStyle/>
-          <ns1:p>
-            <ns1:pPr>
-              <ns1:defRPr sz="2325" b="0">
-                <ns1:solidFill>
-                  <ns1:srgbClr val="111827"/>
-                </ns1:solidFill>
-                <ns1:latin typeface="Helvetica Neue"/>
-                <ns1:ea typeface="Helvetica Neue"/>
-                <ns1:cs typeface="Helvetica Neue"/>
-              </ns1:defRPr>
-            </ns1:pPr>
-            <ns1:r>
-              <ns1:rPr sz="2325" b="0">
-                <ns1:solidFill>
-                  <ns1:srgbClr val="111827"/>
-                </ns1:solidFill>
-                <ns1:latin typeface="Helvetica Neue"/>
-                <ns1:ea typeface="Helvetica Neue"/>
-                <ns1:cs typeface="Helvetica Neue"/>
-              </ns1:rPr>
-              <ns1:t>Access pattern: the data an application repeatedly reads or changes.</ns1:t>
-            </ns1:r>
-          </ns1:p>
-        </ns0:txBody>
-      </ns0:sp>
-      <ns0:sp>
-        <ns0:nvSpPr>
-          <ns0:cNvPr id="14" name="access-example">
-            <ns1:extLst>
-              <ns1:ext uri="{FF2B5EF4-FFF2-40B4-BE49-F238E27FC236}">
-                <ns3:creationId id="{F52199B9-DCE1-4C04-B9C8-B4457DADE6E3}"/>
-              </ns1:ext>
-            </ns1:extLst>
-          </ns0:cNvPr>
-          <ns0:cNvSpPr>
-            <ns1:spLocks noGrp="1"/>
-          </ns0:cNvSpPr>
-          <ns0:nvPr/>
-        </ns0:nvSpPr>
-        <ns0:spPr>
-          <ns1:xfrm>
-            <ns1:off x="6848475" y="3810000"/>
-            <ns1:ext cx="4667250" cy="1971675"/>
-          </ns1:xfrm>
-          <ns1:prstGeom prst="rect">
-            <ns1:avLst/>
-          </ns1:prstGeom>
-          <ns1:noFill/>
-          <ns1:ln w="0">
-            <ns1:noFill/>
-          </ns1:ln>
-        </ns0:spPr>
-        <ns0:txBody>
-          <ns1:bodyPr wrap="square" lIns="0" tIns="0" rIns="0" bIns="0" anchor="t">
-            <ns1:noAutofit/>
-          </ns1:bodyPr>
-          <ns1:lstStyle/>
-          <ns1:p>
-            <ns1:pPr>
-              <ns1:defRPr sz="2250" b="0">
-                <ns1:solidFill>
-                  <ns1:srgbClr val="111827"/>
-                </ns1:solidFill>
-                <ns1:latin typeface="Helvetica Neue"/>
-                <ns1:ea typeface="Helvetica Neue"/>
-                <ns1:cs typeface="Helvetica Neue"/>
-              </ns1:defRPr>
-            </ns1:pPr>
-            <ns1:r>
-              <ns1:rPr sz="2250" b="0">
-                <ns1:solidFill>
-                  <ns1:srgbClr val="111827"/>
-                </ns1:solidFill>
-                <ns1:latin typeface="Helvetica Neue"/>
-                <ns1:ea typeface="Helvetica Neue"/>
-                <ns1:cs typeface="Helvetica Neue"/>
-              </ns1:rPr>
-              <ns1:t>Opening ticket 1001 and its latest events is one pattern.</ns1:t>
-            </ns1:r>
-          </ns1:p>
-          <ns1:p>
-            <ns1:r>
-              <ns1:t/>
-            </ns1:r>
-          </ns1:p>
-          <ns1:p>
-            <ns1:pPr>
-              <ns1:defRPr sz="2250" b="0">
-                <ns1:solidFill>
-                  <ns1:srgbClr val="111827"/>
-                </ns1:solidFill>
-                <ns1:latin typeface="Helvetica Neue"/>
-                <ns1:ea typeface="Helvetica Neue"/>
-                <ns1:cs typeface="Helvetica Neue"/>
-              </ns1:defRPr>
-            </ns1:pPr>
-            <ns1:r>
-              <ns1:rPr sz="2250" b="0">
-                <ns1:solidFill>
-                  <ns1:srgbClr val="111827"/>
-                </ns1:solidFill>
-                <ns1:latin typeface="Helvetica Neue"/>
-                <ns1:ea typeface="Helvetica Neue"/>
-                <ns1:cs typeface="Helvetica Neue"/>
-              </ns1:rPr>
-              <ns1:t>Counting every event by type is another.</ns1:t>
-            </ns1:r>
-          </ns1:p>
-        </ns0:txBody>
-      </ns0:sp>
-      <ns0:sp>
-        <ns0:nvSpPr>
-          <ns0:cNvPr id="15" name="access-choice">
-            <ns1:extLst>
-              <ns1:ext uri="{FF2B5EF4-FFF2-40B4-BE49-F238E27FC236}">
-                <ns3:creationId id="{FC8E327B-D92A-45F8-A0DB-A12A6EEC21FB}"/>
-              </ns1:ext>
-            </ns1:extLst>
-          </ns0:cNvPr>
-          <ns0:cNvSpPr>
-            <ns1:spLocks noGrp="1"/>
-          </ns0:cNvSpPr>
-          <ns0:nvPr/>
-        </ns0:nvSpPr>
-        <ns0:spPr>
-          <ns1:xfrm>
-            <ns1:off x="723900" y="6067425"/>
-            <ns1:ext cx="10668000" cy="352425"/>
-          </ns1:xfrm>
-          <ns1:prstGeom prst="rect">
-            <ns1:avLst/>
-          </ns1:prstGeom>
-          <ns1:noFill/>
-          <ns1:ln w="0">
-            <ns1:noFill/>
-          </ns1:ln>
-        </ns0:spPr>
-        <ns0:txBody>
-          <ns1:bodyPr wrap="square" lIns="0" tIns="0" rIns="0" bIns="0" anchor="t">
-            <ns1:noAutofit/>
-          </ns1:bodyPr>
-          <ns1:lstStyle/>
-          <ns1:p>
-            <ns1:pPr>
-              <ns1:defRPr sz="1950" b="0">
-                <ns1:solidFill>
-                  <ns1:srgbClr val="111827"/>
-                </ns1:solidFill>
-                <ns1:latin typeface="Helvetica Neue"/>
-                <ns1:ea typeface="Helvetica Neue"/>
-                <ns1:cs typeface="Helvetica Neue"/>
-              </ns1:defRPr>
-            </ns1:pPr>
-            <ns1:r>
-              <ns1:rPr sz="1950" b="0">
-                <ns1:solidFill>
-                  <ns1:srgbClr val="111827"/>
-                </ns1:solidFill>
-                <ns1:latin typeface="Helvetica Neue"/>
-                <ns1:ea typeface="Helvetica Neue"/>
-                <ns1:cs typeface="Helvetica Neue"/>
-              </ns1:rPr>
-              <ns1:t>One application may benefit from more than one representation.</ns1:t>
-            </ns1:r>
-          </ns1:p>
-        </ns0:txBody>
-      </ns0:sp>
-    </ns0:spTree>
-    <ns0:extLst>
-      <ns0:ext uri="{BB962C8B-B14F-4D97-AF65-F5344CB8AC3E}">
-        <ns4:creationId val="335246399"/>
-      </ns0:ext>
-    </ns0:extLst>
-  </ns0:cSld>
-</ns0:sld>
+<p:sld xmlns:p="http://schemas.openxmlformats.org/presentationml/2006/main">
+  <p:cSld>
+    <p:bg>
+      <p:bgPr>
+        <a:solidFill xmlns:a="http://schemas.openxmlformats.org/drawingml/2006/main">
+          <a:srgbClr val="FCFCFA"/>
+        </a:solidFill>
+      </p:bgPr>
+    </p:bg>
+    <p:spTree>
+      <p:nvGrpSpPr>
+        <p:cNvPr id="1" name=""/>
+        <p:cNvGrpSpPr/>
+        <p:nvPr/>
+      </p:nvGrpSpPr>
+      <p:grpSpPr>
+        <a:xfrm xmlns:a="http://schemas.openxmlformats.org/drawingml/2006/main"/>
+      </p:grpSpPr>
+      <p:pic>
+        <p:nvPicPr>
+          <p:cNvPr id="16" name=""/>
+          <p:cNvPicPr>
+            <a:picLocks xmlns:a="http://schemas.openxmlformats.org/drawingml/2006/main" noChangeAspect="1"/>
+          </p:cNvPicPr>
+          <p:nvPr/>
+        </p:nvPicPr>
+        <p:blipFill>
+          <a:blip xmlns:r="http://schemas.openxmlformats.org/officeDocument/2006/relationships" xmlns:a="http://schemas.openxmlformats.org/drawingml/2006/main" r:embed="R944d24afa02f4e5a"/>
+          <a:stretch xmlns:a="http://schemas.openxmlformats.org/drawingml/2006/main"/>
+        </p:blipFill>
+        <p:spPr>
+          <a:xfrm xmlns:a="http://schemas.openxmlformats.org/drawingml/2006/main">
+            <a:off x="666750" y="1676400"/>
+            <a:ext cx="5657850" cy="4114800"/>
+          </a:xfrm>
+          <a:prstGeom xmlns:a="http://schemas.openxmlformats.org/drawingml/2006/main" prst="rect">
+            <a:avLst/>
+          </a:prstGeom>
+        </p:spPr>
+      </p:pic>
+      <p:sp>
+        <p:nvSpPr>
+          <p:cNvPr id="9" name="eyebrow">
+            <a:extLst xmlns:a="http://schemas.openxmlformats.org/drawingml/2006/main">
+              <a:ext uri="{FF2B5EF4-FFF2-40B4-BE49-F238E27FC236}">
+                <a16:creationId xmlns:a16="http://schemas.microsoft.com/office/drawing/2014/main" id="{468F18FB-D37E-4965-B1FB-8887D3F72C10}"/>
+              </a:ext>
+            </a:extLst>
+          </p:cNvPr>
+          <p:cNvSpPr>
+            <a:spLocks xmlns:a="http://schemas.openxmlformats.org/drawingml/2006/main" noGrp="1"/>
+          </p:cNvSpPr>
+          <p:nvPr/>
+        </p:nvSpPr>
+        <p:spPr>
+          <a:xfrm xmlns:a="http://schemas.openxmlformats.org/drawingml/2006/main">
+            <a:off x="609600" y="295275"/>
+            <a:ext cx="5715000" cy="228600"/>
+          </a:xfrm>
+          <a:prstGeom xmlns:a="http://schemas.openxmlformats.org/drawingml/2006/main" prst="rect">
+            <a:avLst/>
+          </a:prstGeom>
+          <a:noFill xmlns:a="http://schemas.openxmlformats.org/drawingml/2006/main"/>
+          <a:ln xmlns:a="http://schemas.openxmlformats.org/drawingml/2006/main" w="0">
+            <a:noFill/>
+          </a:ln>
+        </p:spPr>
+        <p:txBody>
+          <a:bodyPr xmlns:a="http://schemas.openxmlformats.org/drawingml/2006/main" wrap="square" lIns="0" tIns="0" rIns="0" bIns="0" anchor="t">
+            <a:noAutofit/>
+          </a:bodyPr>
+          <a:lstStyle xmlns:a="http://schemas.openxmlformats.org/drawingml/2006/main"/>
+          <a:p xmlns:a="http://schemas.openxmlformats.org/drawingml/2006/main">
+            <a:pPr>
+              <a:defRPr sz="1050" b="1">
+                <a:solidFill>
+                  <a:srgbClr val="214AE8"/>
+                </a:solidFill>
+                <a:latin typeface="Helvetica Neue"/>
+                <a:ea typeface="Helvetica Neue"/>
+                <a:cs typeface="Helvetica Neue"/>
+              </a:defRPr>
+            </a:pPr>
+            <a:r>
+              <a:rPr sz="1050" b="1">
+                <a:solidFill>
+                  <a:srgbClr val="214AE8"/>
+                </a:solidFill>
+                <a:latin typeface="Helvetica Neue"/>
+                <a:ea typeface="Helvetica Neue"/>
+                <a:cs typeface="Helvetica Neue"/>
+              </a:rPr>
+              <a:t>WEEK 09  /  CST4714</a:t>
+            </a:r>
+          </a:p>
+        </p:txBody>
+      </p:sp>
+      <p:sp>
+        <p:nvSpPr>
+          <p:cNvPr id="10" name="slide-title">
+            <a:extLst xmlns:a="http://schemas.openxmlformats.org/drawingml/2006/main">
+              <a:ext uri="{FF2B5EF4-FFF2-40B4-BE49-F238E27FC236}">
+                <a16:creationId xmlns:a16="http://schemas.microsoft.com/office/drawing/2014/main" id="{558CB877-064B-4830-BC43-3DAAEC31D314}"/>
+              </a:ext>
+            </a:extLst>
+          </p:cNvPr>
+          <p:cNvSpPr>
+            <a:spLocks xmlns:a="http://schemas.openxmlformats.org/drawingml/2006/main" noGrp="1"/>
+          </p:cNvSpPr>
+          <p:nvPr/>
+        </p:nvSpPr>
+        <p:spPr>
+          <a:xfrm xmlns:a="http://schemas.openxmlformats.org/drawingml/2006/main">
+            <a:off x="609600" y="619125"/>
+            <a:ext cx="10972800" cy="628650"/>
+          </a:xfrm>
+          <a:prstGeom xmlns:a="http://schemas.openxmlformats.org/drawingml/2006/main" prst="rect">
+            <a:avLst/>
+          </a:prstGeom>
+          <a:noFill xmlns:a="http://schemas.openxmlformats.org/drawingml/2006/main"/>
+          <a:ln xmlns:a="http://schemas.openxmlformats.org/drawingml/2006/main" w="0">
+            <a:noFill/>
+          </a:ln>
+        </p:spPr>
+        <p:txBody>
+          <a:bodyPr xmlns:a="http://schemas.openxmlformats.org/drawingml/2006/main" wrap="square" lIns="0" tIns="0" rIns="0" bIns="0" anchor="t">
+            <a:noAutofit/>
+          </a:bodyPr>
+          <a:lstStyle xmlns:a="http://schemas.openxmlformats.org/drawingml/2006/main"/>
+          <a:p xmlns:a="http://schemas.openxmlformats.org/drawingml/2006/main">
+            <a:pPr>
+              <a:defRPr sz="2775" b="1">
+                <a:solidFill>
+                  <a:srgbClr val="111827"/>
+                </a:solidFill>
+                <a:latin typeface="Helvetica Neue"/>
+                <a:ea typeface="Helvetica Neue"/>
+                <a:cs typeface="Helvetica Neue"/>
+              </a:defRPr>
+            </a:pPr>
+            <a:r>
+              <a:rPr sz="2775" b="1">
+                <a:solidFill>
+                  <a:srgbClr val="111827"/>
+                </a:solidFill>
+                <a:latin typeface="Helvetica Neue"/>
+                <a:ea typeface="Helvetica Neue"/>
+                <a:cs typeface="Helvetica Neue"/>
+              </a:rPr>
+              <a:t>Model families and access patterns</a:t>
+            </a:r>
+          </a:p>
+        </p:txBody>
+      </p:sp>
+      <p:sp>
+        <p:nvSpPr>
+          <p:cNvPr id="11" name="">
+            <a:extLst xmlns:a="http://schemas.openxmlformats.org/drawingml/2006/main">
+              <a:ext uri="{FF2B5EF4-FFF2-40B4-BE49-F238E27FC236}">
+                <a16:creationId xmlns:a16="http://schemas.microsoft.com/office/drawing/2014/main" id="{AF601EED-1672-4E16-B0E8-C6D6AACA4113}"/>
+              </a:ext>
+            </a:extLst>
+          </p:cNvPr>
+          <p:cNvSpPr>
+            <a:spLocks xmlns:a="http://schemas.openxmlformats.org/drawingml/2006/main" noGrp="1"/>
+          </p:cNvSpPr>
+          <p:nvPr/>
+        </p:nvSpPr>
+        <p:spPr>
+          <a:xfrm xmlns:a="http://schemas.openxmlformats.org/drawingml/2006/main">
+            <a:off x="609600" y="1295400"/>
+            <a:ext cx="10972800" cy="9525"/>
+          </a:xfrm>
+          <a:prstGeom xmlns:a="http://schemas.openxmlformats.org/drawingml/2006/main" prst="rect">
+            <a:avLst/>
+          </a:prstGeom>
+          <a:solidFill xmlns:a="http://schemas.openxmlformats.org/drawingml/2006/main">
+            <a:srgbClr val="CBD5E1"/>
+          </a:solidFill>
+          <a:ln xmlns:a="http://schemas.openxmlformats.org/drawingml/2006/main" w="0">
+            <a:solidFill>
+              <a:srgbClr val="CBD5E1"/>
+            </a:solidFill>
+          </a:ln>
+        </p:spPr>
+      </p:sp>
+      <p:sp>
+        <p:nvSpPr>
+          <p:cNvPr id="12" name="slide-number">
+            <a:extLst xmlns:a="http://schemas.openxmlformats.org/drawingml/2006/main">
+              <a:ext uri="{FF2B5EF4-FFF2-40B4-BE49-F238E27FC236}">
+                <a16:creationId xmlns:a16="http://schemas.microsoft.com/office/drawing/2014/main" id="{939911BD-2E67-4A5D-A723-C95C82DB1C34}"/>
+              </a:ext>
+            </a:extLst>
+          </p:cNvPr>
+          <p:cNvSpPr>
+            <a:spLocks xmlns:a="http://schemas.openxmlformats.org/drawingml/2006/main" noGrp="1"/>
+          </p:cNvSpPr>
+          <p:nvPr/>
+        </p:nvSpPr>
+        <p:spPr>
+          <a:xfrm xmlns:a="http://schemas.openxmlformats.org/drawingml/2006/main">
+            <a:off x="11125200" y="6467475"/>
+            <a:ext cx="457200" cy="190500"/>
+          </a:xfrm>
+          <a:prstGeom xmlns:a="http://schemas.openxmlformats.org/drawingml/2006/main" prst="rect">
+            <a:avLst/>
+          </a:prstGeom>
+          <a:noFill xmlns:a="http://schemas.openxmlformats.org/drawingml/2006/main"/>
+          <a:ln xmlns:a="http://schemas.openxmlformats.org/drawingml/2006/main" w="0">
+            <a:noFill/>
+          </a:ln>
+        </p:spPr>
+        <p:txBody>
+          <a:bodyPr xmlns:a="http://schemas.openxmlformats.org/drawingml/2006/main" wrap="square" lIns="0" tIns="0" rIns="0" bIns="0" anchor="t">
+            <a:noAutofit/>
+          </a:bodyPr>
+          <a:lstStyle xmlns:a="http://schemas.openxmlformats.org/drawingml/2006/main"/>
+          <a:p xmlns:a="http://schemas.openxmlformats.org/drawingml/2006/main">
+            <a:pPr>
+              <a:defRPr sz="900" b="0">
+                <a:solidFill>
+                  <a:srgbClr val="64748B"/>
+                </a:solidFill>
+                <a:latin typeface="Helvetica Neue"/>
+                <a:ea typeface="Helvetica Neue"/>
+                <a:cs typeface="Helvetica Neue"/>
+              </a:defRPr>
+            </a:pPr>
+            <a:r>
+              <a:rPr sz="900" b="0">
+                <a:solidFill>
+                  <a:srgbClr val="64748B"/>
+                </a:solidFill>
+                <a:latin typeface="Helvetica Neue"/>
+                <a:ea typeface="Helvetica Neue"/>
+                <a:cs typeface="Helvetica Neue"/>
+              </a:rPr>
+              <a:t>04</a:t>
+            </a:r>
+          </a:p>
+        </p:txBody>
+      </p:sp>
+      <p:sp>
+        <p:nvSpPr>
+          <p:cNvPr id="13" name="access-definition">
+            <a:extLst xmlns:a="http://schemas.openxmlformats.org/drawingml/2006/main">
+              <a:ext uri="{FF2B5EF4-FFF2-40B4-BE49-F238E27FC236}">
+                <a16:creationId xmlns:a16="http://schemas.microsoft.com/office/drawing/2014/main" id="{9AC8372B-6E76-427A-9731-2D8B3AFC2E15}"/>
+              </a:ext>
+            </a:extLst>
+          </p:cNvPr>
+          <p:cNvSpPr>
+            <a:spLocks xmlns:a="http://schemas.openxmlformats.org/drawingml/2006/main" noGrp="1"/>
+          </p:cNvSpPr>
+          <p:nvPr/>
+        </p:nvSpPr>
+        <p:spPr>
+          <a:xfrm xmlns:a="http://schemas.openxmlformats.org/drawingml/2006/main">
+            <a:off x="6848475" y="1943100"/>
+            <a:ext cx="4667250" cy="1352550"/>
+          </a:xfrm>
+          <a:prstGeom xmlns:a="http://schemas.openxmlformats.org/drawingml/2006/main" prst="rect">
+            <a:avLst/>
+          </a:prstGeom>
+          <a:noFill xmlns:a="http://schemas.openxmlformats.org/drawingml/2006/main"/>
+          <a:ln xmlns:a="http://schemas.openxmlformats.org/drawingml/2006/main" w="0">
+            <a:noFill/>
+          </a:ln>
+        </p:spPr>
+        <p:txBody>
+          <a:bodyPr xmlns:a="http://schemas.openxmlformats.org/drawingml/2006/main" wrap="square" lIns="0" tIns="0" rIns="0" bIns="0" anchor="t">
+            <a:noAutofit/>
+          </a:bodyPr>
+          <a:lstStyle xmlns:a="http://schemas.openxmlformats.org/drawingml/2006/main"/>
+          <a:p xmlns:a="http://schemas.openxmlformats.org/drawingml/2006/main">
+            <a:pPr>
+              <a:defRPr sz="2325" b="0">
+                <a:solidFill>
+                  <a:srgbClr val="111827"/>
+                </a:solidFill>
+                <a:latin typeface="Helvetica Neue"/>
+                <a:ea typeface="Helvetica Neue"/>
+                <a:cs typeface="Helvetica Neue"/>
+              </a:defRPr>
+            </a:pPr>
+            <a:r>
+              <a:rPr sz="2325" b="0">
+                <a:solidFill>
+                  <a:srgbClr val="111827"/>
+                </a:solidFill>
+                <a:latin typeface="Helvetica Neue"/>
+                <a:ea typeface="Helvetica Neue"/>
+                <a:cs typeface="Helvetica Neue"/>
+              </a:rPr>
+              <a:t>Access pattern: the data an application repeatedly reads or changes.</a:t>
+            </a:r>
+          </a:p>
+        </p:txBody>
+      </p:sp>
+      <p:sp>
+        <p:nvSpPr>
+          <p:cNvPr id="14" name="access-example">
+            <a:extLst xmlns:a="http://schemas.openxmlformats.org/drawingml/2006/main">
+              <a:ext uri="{FF2B5EF4-FFF2-40B4-BE49-F238E27FC236}">
+                <a16:creationId xmlns:a16="http://schemas.microsoft.com/office/drawing/2014/main" id="{F52199B9-DCE1-4C04-B9C8-B4457DADE6E3}"/>
+              </a:ext>
+            </a:extLst>
+          </p:cNvPr>
+          <p:cNvSpPr>
+            <a:spLocks xmlns:a="http://schemas.openxmlformats.org/drawingml/2006/main" noGrp="1"/>
+          </p:cNvSpPr>
+          <p:nvPr/>
+        </p:nvSpPr>
+        <p:spPr>
+          <a:xfrm xmlns:a="http://schemas.openxmlformats.org/drawingml/2006/main">
+            <a:off x="6848475" y="3810000"/>
+            <a:ext cx="4667250" cy="1971675"/>
+          </a:xfrm>
+          <a:prstGeom xmlns:a="http://schemas.openxmlformats.org/drawingml/2006/main" prst="rect">
+            <a:avLst/>
+          </a:prstGeom>
+          <a:noFill xmlns:a="http://schemas.openxmlformats.org/drawingml/2006/main"/>
+          <a:ln xmlns:a="http://schemas.openxmlformats.org/drawingml/2006/main" w="0">
+            <a:noFill/>
+          </a:ln>
+        </p:spPr>
+        <p:txBody>
+          <a:bodyPr xmlns:a="http://schemas.openxmlformats.org/drawingml/2006/main" wrap="square" lIns="0" tIns="0" rIns="0" bIns="0" anchor="t">
+            <a:noAutofit/>
+          </a:bodyPr>
+          <a:lstStyle xmlns:a="http://schemas.openxmlformats.org/drawingml/2006/main"/>
+          <a:p xmlns:a="http://schemas.openxmlformats.org/drawingml/2006/main">
+            <a:pPr>
+              <a:defRPr sz="2250" b="0">
+                <a:solidFill>
+                  <a:srgbClr val="111827"/>
+                </a:solidFill>
+                <a:latin typeface="Helvetica Neue"/>
+                <a:ea typeface="Helvetica Neue"/>
+                <a:cs typeface="Helvetica Neue"/>
+              </a:defRPr>
+            </a:pPr>
+            <a:r>
+              <a:rPr sz="2250" b="0">
+                <a:solidFill>
+                  <a:srgbClr val="111827"/>
+                </a:solidFill>
+                <a:latin typeface="Helvetica Neue"/>
+                <a:ea typeface="Helvetica Neue"/>
+                <a:cs typeface="Helvetica Neue"/>
+              </a:rPr>
+              <a:t>Opening ticket 1001 and its latest events is one pattern.</a:t>
+            </a:r>
+          </a:p>
+          <a:p xmlns:a="http://schemas.openxmlformats.org/drawingml/2006/main">
+            <a:r>
+              <a:t/>
+            </a:r>
+          </a:p>
+          <a:p xmlns:a="http://schemas.openxmlformats.org/drawingml/2006/main">
+            <a:pPr>
+              <a:defRPr sz="2250" b="0">
+                <a:solidFill>
+                  <a:srgbClr val="111827"/>
+                </a:solidFill>
+                <a:latin typeface="Helvetica Neue"/>
+                <a:ea typeface="Helvetica Neue"/>
+                <a:cs typeface="Helvetica Neue"/>
+              </a:defRPr>
+            </a:pPr>
+            <a:r>
+              <a:rPr sz="2250" b="0">
+                <a:solidFill>
+                  <a:srgbClr val="111827"/>
+                </a:solidFill>
+                <a:latin typeface="Helvetica Neue"/>
+                <a:ea typeface="Helvetica Neue"/>
+                <a:cs typeface="Helvetica Neue"/>
+              </a:rPr>
+              <a:t>Counting every event by type is another.</a:t>
+            </a:r>
+          </a:p>
+        </p:txBody>
+      </p:sp>
+      <p:sp>
+        <p:nvSpPr>
+          <p:cNvPr id="15" name="access-choice">
+            <a:extLst xmlns:a="http://schemas.openxmlformats.org/drawingml/2006/main">
+              <a:ext uri="{FF2B5EF4-FFF2-40B4-BE49-F238E27FC236}">
+                <a16:creationId xmlns:a16="http://schemas.microsoft.com/office/drawing/2014/main" id="{FC8E327B-D92A-45F8-A0DB-A12A6EEC21FB}"/>
+              </a:ext>
+            </a:extLst>
+          </p:cNvPr>
+          <p:cNvSpPr>
+            <a:spLocks xmlns:a="http://schemas.openxmlformats.org/drawingml/2006/main" noGrp="1"/>
+          </p:cNvSpPr>
+          <p:nvPr/>
+        </p:nvSpPr>
+        <p:spPr>
+          <a:xfrm xmlns:a="http://schemas.openxmlformats.org/drawingml/2006/main">
+            <a:off x="723900" y="6067425"/>
+            <a:ext cx="10668000" cy="352425"/>
+          </a:xfrm>
+          <a:prstGeom xmlns:a="http://schemas.openxmlformats.org/drawingml/2006/main" prst="rect">
+            <a:avLst/>
+          </a:prstGeom>
+          <a:noFill xmlns:a="http://schemas.openxmlformats.org/drawingml/2006/main"/>
+          <a:ln xmlns:a="http://schemas.openxmlformats.org/drawingml/2006/main" w="0">
+            <a:noFill/>
+          </a:ln>
+        </p:spPr>
+        <p:txBody>
+          <a:bodyPr xmlns:a="http://schemas.openxmlformats.org/drawingml/2006/main" wrap="square" lIns="0" tIns="0" rIns="0" bIns="0" anchor="t">
+            <a:noAutofit/>
+          </a:bodyPr>
+          <a:lstStyle xmlns:a="http://schemas.openxmlformats.org/drawingml/2006/main"/>
+          <a:p xmlns:a="http://schemas.openxmlformats.org/drawingml/2006/main">
+            <a:pPr>
+              <a:defRPr sz="1950" b="0">
+                <a:solidFill>
+                  <a:srgbClr val="111827"/>
+                </a:solidFill>
+                <a:latin typeface="Helvetica Neue"/>
+                <a:ea typeface="Helvetica Neue"/>
+                <a:cs typeface="Helvetica Neue"/>
+              </a:defRPr>
+            </a:pPr>
+            <a:r>
+              <a:rPr sz="1950" b="0">
+                <a:solidFill>
+                  <a:srgbClr val="111827"/>
+                </a:solidFill>
+                <a:latin typeface="Helvetica Neue"/>
+                <a:ea typeface="Helvetica Neue"/>
+                <a:cs typeface="Helvetica Neue"/>
+              </a:rPr>
+              <a:t>One application may benefit from more than one representation.</a:t>
+            </a:r>
+          </a:p>
+        </p:txBody>
+      </p:sp>
+    </p:spTree>
+    <p:extLst>
+      <p:ext uri="{BB962C8B-B14F-4D97-AF65-F5344CB8AC3E}">
+        <p14:creationId xmlns:p14="http://schemas.microsoft.com/office/powerpoint/2010/main" val="335246399"/>
+      </p:ext>
+    </p:extLst>
+  </p:cSld>
+</p:sld>
 </file>
 
 <file path=ppt/slides/slide5.xml><?xml version="1.0" encoding="utf-8"?>

</xml_diff>

<commit_message>
Complete Week 9 spoken scripts and clarify tool orientation
</commit_message>
<xml_diff>
--- a/week_09/week_09_nosql_models_json.pptx
+++ b/week_09/week_09_nosql_models_json.pptx
@@ -2683,28 +2683,44 @@
           <a:lstStyle xmlns:a="http://schemas.openxmlformats.org/drawingml/2006/main"/>
           <a:p xmlns:a="http://schemas.openxmlformats.org/drawingml/2006/main">
             <a:r>
-              <a:t>Now let me show you where you will write the lab. GitHub can edit text right in your browser, with no Git installed. Read the path at the top. In your own repository, choose Add file, then Create new file. Name it week_09_json_models.md. The dot md says this is a Markdown file.</a:t>
-            </a:r>
-          </a:p>
-          <a:p xmlns:a="http://schemas.openxmlformats.org/drawingml/2006/main"/>
+              <a:t>Now let me show you one place you can write the lab. You can also use any plain text editor. GitHub can edit text right in your browser, with no Git installed. Read the path at the top. In your own repository, choose Add file, then Create new file. Name it week_09_json_models.md. The dot md says this is a Markdown file.</a:t>
+            </a:r>
+          </a:p>
+          <a:p xmlns:a="http://schemas.openxmlformats.org/drawingml/2006/main">
+            <a:r>
+              <a:t/>
+            </a:r>
+          </a:p>
           <a:p xmlns:a="http://schemas.openxmlformats.org/drawingml/2006/main">
             <a:r>
               <a:t>Look at the example in the middle. A Markdown heading, Referenced design. Then three backticks and the word json. That opens a code block. Then the JSON itself: ticket_id 1004, assignee_id null. Then three backticks again to close it. The backticks belong to Markdown. They are not part of your JSON. And your explanation goes below the JSON block, outside the fences.</a:t>
             </a:r>
           </a:p>
-          <a:p xmlns:a="http://schemas.openxmlformats.org/drawingml/2006/main"/>
+          <a:p xmlns:a="http://schemas.openxmlformats.org/drawingml/2006/main">
+            <a:r>
+              <a:t/>
+            </a:r>
+          </a:p>
           <a:p xmlns:a="http://schemas.openxmlformats.org/drawingml/2006/main">
             <a:r>
               <a:t>Now read the bottom carefully, because people get this wrong. Preview checks the Markdown display. It makes the JSON look nice in a code box. Commit changes saves the text in your repository's history. Neither step validates the JSON syntax, and neither checks that your facts match the CSV. That part is your job, so reread your quotes, commas, and brackets before you submit.</a:t>
             </a:r>
           </a:p>
-          <a:p xmlns:a="http://schemas.openxmlformats.org/drawingml/2006/main"/>
+          <a:p xmlns:a="http://schemas.openxmlformats.org/drawingml/2006/main">
+            <a:r>
+              <a:t/>
+            </a:r>
+          </a:p>
           <a:p xmlns:a="http://schemas.openxmlformats.org/drawingml/2006/main">
             <a:r>
               <a:t>Then download the file and submit it to Brightspace. A public repository is not required, and if GitHub is unavailable, any plain text editor can make the same Markdown file. Use only the synthetic course data, and never put a password or connection string in the file or in your commit history.</a:t>
             </a:r>
           </a:p>
-          <a:p xmlns:a="http://schemas.openxmlformats.org/drawingml/2006/main"/>
+          <a:p xmlns:a="http://schemas.openxmlformats.org/drawingml/2006/main">
+            <a:r>
+              <a:t/>
+            </a:r>
+          </a:p>
           <a:p xmlns:a="http://schemas.openxmlformats.org/drawingml/2006/main">
             <a:r>
               <a:t>[Sources]</a:t>
@@ -2910,31 +2926,51 @@
               <a:t>Next week we connect to MongoDB Atlas, so let's get the pieces straight today. Look at the table. Four components, four different jobs.</a:t>
             </a:r>
           </a:p>
-          <a:p xmlns:a="http://schemas.openxmlformats.org/drawingml/2006/main"/>
+          <a:p xmlns:a="http://schemas.openxmlformats.org/drawingml/2006/main">
+            <a:r>
+              <a:t/>
+            </a:r>
+          </a:p>
           <a:p xmlns:a="http://schemas.openxmlformats.org/drawingml/2006/main">
             <a:r>
               <a:t>The Atlas account and project are how you manage the cloud deployment. The free cluster runs the actual database service, with free-tier limits. A database user is what authenticates a database connection. And the IP access list permits a source network to attempt that connection.</a:t>
             </a:r>
           </a:p>
-          <a:p xmlns:a="http://schemas.openxmlformats.org/drawingml/2006/main"/>
+          <a:p xmlns:a="http://schemas.openxmlformats.org/drawingml/2006/main">
+            <a:r>
+              <a:t/>
+            </a:r>
+          </a:p>
           <a:p xmlns:a="http://schemas.openxmlformats.org/drawingml/2006/main">
             <a:r>
               <a:t>Why separate them so carefully? Because being signed into the Atlas website does not mean your Python program is authenticated to the database. And adding your IP address does not replace a database password. Network permission and authentication are two different checks. You saw the same split in the Week 6 triage table: network unreachable is a different failure from password authentication failed.</a:t>
             </a:r>
           </a:p>
-          <a:p xmlns:a="http://schemas.openxmlformats.org/drawingml/2006/main"/>
-          <a:p xmlns:a="http://schemas.openxmlformats.org/drawingml/2006/main">
-            <a:r>
-              <a:t>Read the instructions in the middle. Choose Free, which some screens call M0, and only the access your practice needs. Do not enter a payment card, and never publish your credentials. If a screen offers a paid option or a step is unclear, stop and ask me instead of paying your way around it.</a:t>
-            </a:r>
-          </a:p>
-          <a:p xmlns:a="http://schemas.openxmlformats.org/drawingml/2006/main"/>
+          <a:p xmlns:a="http://schemas.openxmlformats.org/drawingml/2006/main">
+            <a:r>
+              <a:t/>
+            </a:r>
+          </a:p>
+          <a:p xmlns:a="http://schemas.openxmlformats.org/drawingml/2006/main">
+            <a:r>
+              <a:t>Read the instructions in the middle. Choose Free, formerly called M0, and only the access your practice needs. Do not enter a payment card, and never publish your credentials. If a screen offers a paid option or a step is unclear, stop and ask me instead of paying your way around it.</a:t>
+            </a:r>
+          </a:p>
+          <a:p xmlns:a="http://schemas.openxmlformats.org/drawingml/2006/main">
+            <a:r>
+              <a:t/>
+            </a:r>
+          </a:p>
           <a:p xmlns:a="http://schemas.openxmlformats.org/drawingml/2006/main">
             <a:r>
               <a:t>One trap to know about. Add My Current IP Address adds the address Atlas sees from your browser. A Colab runtime can have a different outbound address, so that setting does not automatically let Colab in. We will handle that when we connect. And look at the last line: today's JSON lab needs no cloud connection at all.</a:t>
             </a:r>
           </a:p>
-          <a:p xmlns:a="http://schemas.openxmlformats.org/drawingml/2006/main"/>
+          <a:p xmlns:a="http://schemas.openxmlformats.org/drawingml/2006/main">
+            <a:r>
+              <a:t/>
+            </a:r>
+          </a:p>
           <a:p xmlns:a="http://schemas.openxmlformats.org/drawingml/2006/main">
             <a:r>
               <a:t>[Sources]</a:t>
@@ -2957,7 +2993,7 @@
           </a:p>
           <a:p xmlns:a="http://schemas.openxmlformats.org/drawingml/2006/main">
             <a:r>
-              <a:t>- Setup documentation checked September 8, 2026. Interface labels can change.</a:t>
+              <a:t>- Setup documentation checked October 27, 2026. Interface labels can change.</a:t>
             </a:r>
           </a:p>
         </p:txBody>
@@ -3235,7 +3271,67 @@
           <a:lstStyle/>
           <a:p>
             <a:r>
-              <a:t>These short animations go with this week's reading. Students can watch them before class to preview the mechanisms, or afterwards to review: Same facts, two shapes (1:16); Strict JSON, from the punctuation up (1:20); What embedding costs over time (1:21). Each video is silent with on-screen captions and a subtitle file, and is linked from the Week 9 README. The diagrams are schematic illustrations, not benchmarks.</a:t>
+              <a:t>These three short videos give us another way to follow the changes we have been discussing. They are silent, with captions, so we can stop and talk about what moves. The thumbnails open the videos on GitHub; the Week 9 page also has the files and subtitles.</a:t>
+            </a:r>
+          </a:p>
+          <a:p>
+            <a:r>
+              <a:t/>
+            </a:r>
+          </a:p>
+          <a:p>
+            <a:r>
+              <a:t>For Same facts, two shapes, watch ticket 1001 and its two event IDs. First we see separate records connected by IDs. Then the related details move inside the ticket. Ask yourself: did any promised fact disappear, or did only its location change? The point is to account for the same information in both designs.</a:t>
+            </a:r>
+          </a:p>
+          <a:p>
+            <a:r>
+              <a:t/>
+            </a:r>
+          </a:p>
+          <a:p>
+            <a:r>
+              <a:t>For Strict JSON, from the punctuation up, watch the braces, brackets, quotes, and commas. When the invalid example appears, find both errors before the repair. Then pay attention to missing, null, empty, and zero. They can look like small differences in text but mean different things to an application.</a:t>
+            </a:r>
+          </a:p>
+          <a:p>
+            <a:r>
+              <a:t/>
+            </a:r>
+          </a:p>
+          <a:p>
+            <a:r>
+              <a:t>For What embedding costs over time, predict what happens when a person changes their name. An embedded current name needs to be refreshed; an intentionally historical name has a different meaning. Then watch the events grow. A bounded preview can make the ticket page convenient, but the complete history still needs a home and the preview needs a refresh rule.</a:t>
+            </a:r>
+          </a:p>
+          <a:p>
+            <a:r>
+              <a:t/>
+            </a:r>
+          </a:p>
+          <a:p>
+            <a:r>
+              <a:t>These are illustrations, not timing tests. For your lab, keep all three events for ticket 1003 in both designs. Use the videos to check your reasoning, then explain the read and the update consequences in your own paragraph.</a:t>
+            </a:r>
+          </a:p>
+          <a:p>
+            <a:r>
+              <a:t/>
+            </a:r>
+          </a:p>
+          <a:p>
+            <a:r>
+              <a:t>[Sources]</a:t>
+            </a:r>
+          </a:p>
+          <a:p>
+            <a:r>
+              <a:t>- Course-created Week 9 videos and captions in videos/README.md.</a:t>
+            </a:r>
+          </a:p>
+          <a:p>
+            <a:r>
+              <a:t>- Week 9 lab, One Ticket, Two JSON Designs.</a:t>
             </a:r>
           </a:p>
         </p:txBody>

</xml_diff>